<commit_message>
Figure 3c: larger labels
Co-Authored-By: Claude Opus 5.5 <noreply@anthropic.com>
</commit_message>
<xml_diff>
--- a/figures/fig_wiring.pptx
+++ b/figures/fig_wiring.pptx
@@ -7,7 +7,7 @@
   <p:sldIdLst>
     <p:sldId id="256" r:id="rId7"/>
   </p:sldIdLst>
-  <p:sldSz cx="6400800" cy="2331720" type="screen4x3"/>
+  <p:sldSz cx="6400800" cy="2468880" type="screen4x3"/>
   <p:notesSz cx="6858000" cy="9144000"/>
   <p:defaultTextStyle>
     <a:defPPr>
@@ -3607,7 +3607,7 @@
           <a:p>
             <a:pPr algn="ctr"/>
             <a:r>
-              <a:rPr sz="620" b="0">
+              <a:rPr sz="680" b="0">
                 <a:solidFill>
                   <a:srgbClr val="0B0B0B"/>
                 </a:solidFill>
@@ -3672,7 +3672,7 @@
         </p:nvSpPr>
         <p:spPr>
           <a:xfrm>
-            <a:off x="4361688" y="501586"/>
+            <a:off x="4361688" y="492442"/>
             <a:ext cx="731520" cy="137160"/>
           </a:xfrm>
           <a:prstGeom prst="rect">
@@ -3688,7 +3688,7 @@
           <a:p>
             <a:pPr algn="ctr"/>
             <a:r>
-              <a:rPr sz="620" b="0">
+              <a:rPr sz="680" b="0">
                 <a:solidFill>
                   <a:srgbClr val="0B0B0B"/>
                 </a:solidFill>
@@ -3769,7 +3769,7 @@
           <a:p>
             <a:pPr algn="ctr"/>
             <a:r>
-              <a:rPr sz="620" b="0">
+              <a:rPr sz="680" b="0">
                 <a:solidFill>
                   <a:srgbClr val="0B0B0B"/>
                 </a:solidFill>
@@ -3850,7 +3850,7 @@
           <a:p>
             <a:pPr algn="ctr"/>
             <a:r>
-              <a:rPr sz="620" b="0">
+              <a:rPr sz="680" b="0">
                 <a:solidFill>
                   <a:srgbClr val="0B0B0B"/>
                 </a:solidFill>
@@ -4075,7 +4075,7 @@
           <a:p>
             <a:pPr algn="ctr"/>
             <a:r>
-              <a:rPr sz="620" b="0">
+              <a:rPr sz="680" b="0">
                 <a:solidFill>
                   <a:srgbClr val="0B0B0B"/>
                 </a:solidFill>
@@ -4140,7 +4140,7 @@
         </p:nvSpPr>
         <p:spPr>
           <a:xfrm>
-            <a:off x="5495544" y="501586"/>
+            <a:off x="5495544" y="492442"/>
             <a:ext cx="731520" cy="137160"/>
           </a:xfrm>
           <a:prstGeom prst="rect">
@@ -4156,7 +4156,7 @@
           <a:p>
             <a:pPr algn="ctr"/>
             <a:r>
-              <a:rPr sz="620" b="0">
+              <a:rPr sz="680" b="0">
                 <a:solidFill>
                   <a:srgbClr val="0B0B0B"/>
                 </a:solidFill>
@@ -4237,7 +4237,7 @@
           <a:p>
             <a:pPr algn="ctr"/>
             <a:r>
-              <a:rPr sz="620" b="0">
+              <a:rPr sz="680" b="0">
                 <a:solidFill>
                   <a:srgbClr val="0B0B0B"/>
                 </a:solidFill>
@@ -4318,7 +4318,7 @@
           <a:p>
             <a:pPr algn="ctr"/>
             <a:r>
-              <a:rPr sz="620" b="0">
+              <a:rPr sz="680" b="0">
                 <a:solidFill>
                   <a:srgbClr val="0B0B0B"/>
                 </a:solidFill>
@@ -4353,7 +4353,7 @@
           <a:p>
             <a:pPr algn="ctr"/>
             <a:r>
-              <a:rPr sz="640" b="0">
+              <a:rPr sz="700" b="0">
                 <a:solidFill>
                   <a:srgbClr val="0B0B0B"/>
                 </a:solidFill>
@@ -4365,7 +4365,7 @@
           <a:p>
             <a:pPr algn="ctr"/>
             <a:r>
-              <a:rPr sz="640" b="0">
+              <a:rPr sz="700" b="0">
                 <a:solidFill>
                   <a:srgbClr val="0B0B0B"/>
                 </a:solidFill>
@@ -4400,7 +4400,7 @@
           <a:p>
             <a:pPr algn="ctr"/>
             <a:r>
-              <a:rPr sz="640" b="0">
+              <a:rPr sz="700" b="0">
                 <a:solidFill>
                   <a:srgbClr val="0B0B0B"/>
                 </a:solidFill>
@@ -4412,7 +4412,7 @@
           <a:p>
             <a:pPr algn="ctr"/>
             <a:r>
-              <a:rPr sz="640" b="0">
+              <a:rPr sz="700" b="0">
                 <a:solidFill>
                   <a:srgbClr val="0B0B0B"/>
                 </a:solidFill>
@@ -4432,7 +4432,7 @@
         <p:spPr>
           <a:xfrm>
             <a:off x="4224528" y="2066543"/>
-            <a:ext cx="2157984" cy="365760"/>
+            <a:ext cx="2157984" cy="384048"/>
           </a:xfrm>
           <a:prstGeom prst="rect">
             <a:avLst/>
@@ -4447,13 +4447,37 @@
           <a:p>
             <a:pPr algn="l"/>
             <a:r>
-              <a:rPr sz="580" b="0">
+              <a:rPr sz="660" b="0">
                 <a:solidFill>
                   <a:srgbClr val="52514E"/>
                 </a:solidFill>
                 <a:latin typeface="Arial"/>
               </a:rPr>
-              <a:t>orange excitatory, blue inhibitory; node area: share of the leading mode; edge width: summed weight</a:t>
+              <a:t>orange excitatory, blue inhibitory</a:t>
+            </a:r>
+          </a:p>
+          <a:p>
+            <a:pPr algn="l"/>
+            <a:r>
+              <a:rPr sz="660" b="0">
+                <a:solidFill>
+                  <a:srgbClr val="52514E"/>
+                </a:solidFill>
+                <a:latin typeface="Arial"/>
+              </a:rPr>
+              <a:t>node area: share of the leading mode</a:t>
+            </a:r>
+          </a:p>
+          <a:p>
+            <a:pPr algn="l"/>
+            <a:r>
+              <a:rPr sz="660" b="0">
+                <a:solidFill>
+                  <a:srgbClr val="52514E"/>
+                </a:solidFill>
+                <a:latin typeface="Arial"/>
+              </a:rPr>
+              <a:t>edge width: summed weight</a:t>
             </a:r>
           </a:p>
         </p:txBody>

</xml_diff>